<commit_message>
Refactor PongState into GameContext
Split the monolithic PongState into PongGameState and ApplicationState, and combine them in a new GameContext. Update function signatures and lifecyle names (restore_mode -> application_finalize, pong_begin -> application_initialize, pong_run -> application_loop) to operate on GameContext/PongGameState. main now initializes, runs, and finalizes using the new context; CRT mode is restored on failure. Minor renames across pong_* helpers to use the new PongGameState. Updated binary docs/pong.pptx.
</commit_message>
<xml_diff>
--- a/docs/pong.pptx
+++ b/docs/pong.pptx
@@ -2,19 +2,19 @@
 <file path=ppt/presentation.xml><?xml version="1.0" encoding="utf-8"?>
 <p:presentation xmlns:p="http://schemas.openxmlformats.org/presentationml/2006/main">
   <p:sldMasterIdLst>
-    <p:sldMasterId xmlns:r="http://schemas.openxmlformats.org/officeDocument/2006/relationships" id="2147483648" r:id="Rdf4b9d1d0e9a4a8a"/>
+    <p:sldMasterId xmlns:r="http://schemas.openxmlformats.org/officeDocument/2006/relationships" id="2147483648" r:id="R66df4e2df071416a"/>
   </p:sldMasterIdLst>
   <p:notesMasterIdLst>
-    <p:notesMasterId xmlns:r="http://schemas.openxmlformats.org/officeDocument/2006/relationships" r:id="R0f83a4a3cd5a4638"/>
+    <p:notesMasterId xmlns:r="http://schemas.openxmlformats.org/officeDocument/2006/relationships" r:id="R6e307ae9a36c4995"/>
   </p:notesMasterIdLst>
   <p:sldIdLst>
-    <p:sldId xmlns:r="http://schemas.openxmlformats.org/officeDocument/2006/relationships" id="256" r:id="R448b802a7eeb477e"/>
-    <p:sldId xmlns:r="http://schemas.openxmlformats.org/officeDocument/2006/relationships" id="257" r:id="R04176bdb5db14711"/>
-    <p:sldId xmlns:r="http://schemas.openxmlformats.org/officeDocument/2006/relationships" id="258" r:id="R4bdf09a2c8a64a16"/>
-    <p:sldId xmlns:r="http://schemas.openxmlformats.org/officeDocument/2006/relationships" id="259" r:id="Rb11ad205b7eb482b"/>
-    <p:sldId xmlns:r="http://schemas.openxmlformats.org/officeDocument/2006/relationships" id="260" r:id="R7096ef38c16b43c9"/>
-    <p:sldId xmlns:r="http://schemas.openxmlformats.org/officeDocument/2006/relationships" id="261" r:id="R5b9aa5e2a13c4db6"/>
-    <p:sldId xmlns:r="http://schemas.openxmlformats.org/officeDocument/2006/relationships" id="262" r:id="Rca0110f3c1674c94"/>
+    <p:sldId xmlns:r="http://schemas.openxmlformats.org/officeDocument/2006/relationships" id="256" r:id="Ref551dca82784c9c"/>
+    <p:sldId xmlns:r="http://schemas.openxmlformats.org/officeDocument/2006/relationships" id="257" r:id="R551ef60064fd449c"/>
+    <p:sldId xmlns:r="http://schemas.openxmlformats.org/officeDocument/2006/relationships" id="258" r:id="R47c23af68fa8430b"/>
+    <p:sldId xmlns:r="http://schemas.openxmlformats.org/officeDocument/2006/relationships" id="259" r:id="Re8797bf716f44f44"/>
+    <p:sldId xmlns:r="http://schemas.openxmlformats.org/officeDocument/2006/relationships" id="260" r:id="Rdc6ca2ff7f15443a"/>
+    <p:sldId xmlns:r="http://schemas.openxmlformats.org/officeDocument/2006/relationships" id="261" r:id="R269235f400bd48be"/>
+    <p:sldId xmlns:r="http://schemas.openxmlformats.org/officeDocument/2006/relationships" id="262" r:id="Ra973e247b6b24569"/>
   </p:sldIdLst>
   <p:sldSz cx="12192000" cy="6858000"/>
   <p:notesSz cx="6858000" cy="9144000"/>
@@ -461,6 +461,11 @@
               <a:t>- Local build definition: pong/src/Makefile</a:t>
             </a:r>
           </a:p>
+          <a:p xmlns:a="http://schemas.openxmlformats.org/drawingml/2006/main">
+            <a:r>
+              <a:t>- Local image: pong/images/teaser.png</a:t>
+            </a:r>
+          </a:p>
         </p:txBody>
       </p:sp>
       <p:sp>
@@ -981,7 +986,7 @@
   </p:cSld>
   <p:clrMap bg1="lt1" tx1="dk1" bg2="lt2" tx2="dk2" accent1="accent1" accent2="accent2" accent3="accent3" accent4="accent4" accent5="accent5" accent6="accent6" hlink="hlink" folHlink="folHlink"/>
   <p:sldLayoutIdLst>
-    <p:sldLayoutId xmlns:r="http://schemas.openxmlformats.org/officeDocument/2006/relationships" id="2147483649" r:id="R4b14de4dfd5f4e44"/>
+    <p:sldLayoutId xmlns:r="http://schemas.openxmlformats.org/officeDocument/2006/relationships" id="2147483649" r:id="Ra685f9b167cc4e8b"/>
   </p:sldLayoutIdLst>
   <p:txStyles>
     <p:titleStyle>
@@ -2074,7 +2079,7 @@
                 <a:ea typeface="Yu Gothic"/>
                 <a:cs typeface="Yu Gothic"/>
               </a:rPr>
-              <a:t>3</a:t>
+              <a:t>60</a:t>
             </a:r>
           </a:p>
         </p:txBody>
@@ -2131,11 +2136,64 @@
                 <a:ea typeface="Yu Gothic"/>
                 <a:cs typeface="Yu Gothic"/>
               </a:rPr>
-              <a:t>PT</a:t>
-            </a:r>
-          </a:p>
-        </p:txBody>
-      </p:sp>
+              <a:t>Hz</a:t>
+            </a:r>
+          </a:p>
+        </p:txBody>
+      </p:sp>
+      <p:sp>
+        <p:nvSpPr>
+          <p:cNvPr id="15" name="teaser-background">
+            <a:extLst xmlns:a="http://schemas.openxmlformats.org/drawingml/2006/main">
+              <a:ext uri="{FF2B5EF4-FFF2-40B4-BE49-F238E27FC236}">
+                <a16:creationId xmlns:a16="http://schemas.microsoft.com/office/drawing/2014/main" id="{45C905A8-2604-4418-890B-A452EF1C2EDA}"/>
+              </a:ext>
+            </a:extLst>
+          </p:cNvPr>
+          <p:cNvSpPr>
+            <a:spLocks xmlns:a="http://schemas.openxmlformats.org/drawingml/2006/main" noGrp="1"/>
+          </p:cNvSpPr>
+          <p:nvPr/>
+        </p:nvSpPr>
+        <p:spPr>
+          <a:xfrm xmlns:a="http://schemas.openxmlformats.org/drawingml/2006/main">
+            <a:off x="6191250" y="495300"/>
+            <a:ext cx="5429250" cy="5619750"/>
+          </a:xfrm>
+          <a:prstGeom xmlns:a="http://schemas.openxmlformats.org/drawingml/2006/main" prst="rect">
+            <a:avLst/>
+          </a:prstGeom>
+          <a:solidFill xmlns:a="http://schemas.openxmlformats.org/drawingml/2006/main">
+            <a:srgbClr val="080808"/>
+          </a:solidFill>
+          <a:ln xmlns:a="http://schemas.openxmlformats.org/drawingml/2006/main" w="0">
+            <a:noFill/>
+            <a:prstDash val="solid"/>
+          </a:ln>
+        </p:spPr>
+      </p:sp>
+      <p:pic>
+        <p:nvPicPr>
+          <p:cNvPr id="31" name=""/>
+          <p:cNvPicPr>
+            <a:picLocks xmlns:a="http://schemas.openxmlformats.org/drawingml/2006/main" noChangeAspect="1"/>
+          </p:cNvPicPr>
+          <p:nvPr/>
+        </p:nvPicPr>
+        <p:blipFill>
+          <a:blip xmlns:r="http://schemas.openxmlformats.org/officeDocument/2006/relationships" xmlns:a="http://schemas.openxmlformats.org/drawingml/2006/main" r:embed="R005826135d504f80"/>
+          <a:stretch xmlns:a="http://schemas.openxmlformats.org/drawingml/2006/main"/>
+        </p:blipFill>
+        <p:spPr>
+          <a:xfrm xmlns:a="http://schemas.openxmlformats.org/drawingml/2006/main">
+            <a:off x="6191250" y="760214"/>
+            <a:ext cx="5429250" cy="5089922"/>
+          </a:xfrm>
+          <a:prstGeom xmlns:a="http://schemas.openxmlformats.org/drawingml/2006/main" prst="rect">
+            <a:avLst/>
+          </a:prstGeom>
+        </p:spPr>
+      </p:pic>
     </p:spTree>
     <p:extLst>
       <p:ext uri="{BB962C8B-B14F-4D97-AF65-F5344CB8AC3E}">
@@ -2217,7 +2275,7 @@
                 <a:ea typeface="Yu Gothic"/>
                 <a:cs typeface="Yu Gothic"/>
               </a:rPr>
-              <a:t>タイトル・対戦・勝者表示を明確に分ける</a:t>
+              <a:t>applicationとGameContextで責務を分離</a:t>
             </a:r>
           </a:p>
         </p:txBody>
@@ -2393,7 +2451,7 @@
                 <a:ea typeface="Yu Gothic"/>
                 <a:cs typeface="Yu Gothic"/>
               </a:rPr>
-              <a:t>画面遷移</a:t>
+              <a:t>applicationの責務</a:t>
             </a:r>
           </a:p>
         </p:txBody>
@@ -2450,15 +2508,44 @@
                 <a:ea typeface="Yu Gothic"/>
                 <a:cs typeface="Yu Gothic"/>
               </a:rPr>
-              <a:t>・title_screen() でモード選択</a:t>
-            </a:r>
-          </a:p>
-          <a:p xmlns:a="http://schemas.openxmlformats.org/drawingml/2006/main">
-            <a:r>
+              <a:t>・application_initialize()</a:t>
+            </a:r>
+          </a:p>
+          <a:p xmlns:a="http://schemas.openxmlformats.org/drawingml/2006/main">
+            <a:r>
+              <a:t>　画面モードと60 Hzを初期化</a:t>
+            </a:r>
+          </a:p>
+          <a:p xmlns:a="http://schemas.openxmlformats.org/drawingml/2006/main">
+            <a:pPr algn="l">
+              <a:buNone/>
+              <a:defRPr sz="1575" b="0">
+                <a:solidFill>
+                  <a:srgbClr val="5D625F"/>
+                </a:solidFill>
+                <a:latin typeface="Yu Gothic"/>
+                <a:ea typeface="Yu Gothic"/>
+                <a:cs typeface="Yu Gothic"/>
+              </a:defRPr>
+            </a:pPr>
+            <a:r>
+              <a:rPr sz="1575" b="0">
+                <a:solidFill>
+                  <a:srgbClr val="5D625F"/>
+                </a:solidFill>
+                <a:latin typeface="Yu Gothic"/>
+                <a:ea typeface="Yu Gothic"/>
+                <a:cs typeface="Yu Gothic"/>
+              </a:rPr>
               <a:t/>
             </a:r>
           </a:p>
           <a:p xmlns:a="http://schemas.openxmlformats.org/drawingml/2006/main">
+            <a:r>
+              <a:t>・application_loop()</a:t>
+            </a:r>
+          </a:p>
+          <a:p xmlns:a="http://schemas.openxmlformats.org/drawingml/2006/main">
             <a:pPr algn="l">
               <a:buNone/>
               <a:defRPr sz="1575" b="0">
@@ -2479,7 +2566,7 @@
                 <a:ea typeface="Yu Gothic"/>
                 <a:cs typeface="Yu Gothic"/>
               </a:rPr>
-              <a:t>・pong_match() で入力・更新・描画</a:t>
+              <a:t>　タイトル・対戦・勝者表示を制御</a:t>
             </a:r>
           </a:p>
           <a:p xmlns:a="http://schemas.openxmlformats.org/drawingml/2006/main">
@@ -2508,12 +2595,7 @@
                 <a:ea typeface="Yu Gothic"/>
                 <a:cs typeface="Yu Gothic"/>
               </a:rPr>
-              <a:t>・winner_screen() を3秒表示</a:t>
-            </a:r>
-          </a:p>
-          <a:p xmlns:a="http://schemas.openxmlformats.org/drawingml/2006/main">
-            <a:r>
-              <a:t/>
+              <a:t>・application_finalize()</a:t>
             </a:r>
           </a:p>
           <a:p xmlns:a="http://schemas.openxmlformats.org/drawingml/2006/main">
@@ -2537,7 +2619,7 @@
                 <a:ea typeface="Yu Gothic"/>
                 <a:cs typeface="Yu Gothic"/>
               </a:rPr>
-              <a:t>・終了後は必ずタイトルへ戻る</a:t>
+              <a:t>　元の画面モードへ復帰</a:t>
             </a:r>
           </a:p>
         </p:txBody>
@@ -2594,7 +2676,7 @@
                 <a:ea typeface="Yu Gothic"/>
                 <a:cs typeface="Yu Gothic"/>
               </a:rPr>
-              <a:t>最新ゲーム仕様</a:t>
+              <a:t>GameContextの構成</a:t>
             </a:r>
           </a:p>
         </p:txBody>
@@ -2651,7 +2733,7 @@
                 <a:ea typeface="Yu Gothic"/>
                 <a:cs typeface="Yu Gothic"/>
               </a:rPr>
-              <a:t>モード12　512 x 512 VRAM</a:t>
+              <a:t>GameContext</a:t>
             </a:r>
           </a:p>
           <a:p xmlns:a="http://schemas.openxmlformats.org/drawingml/2006/main">
@@ -2675,7 +2757,7 @@
                 <a:ea typeface="Yu Gothic"/>
                 <a:cs typeface="Yu Gothic"/>
               </a:rPr>
-              <a:t>可視領域　512 x 480</a:t>
+              <a:t>  application : ApplicationState</a:t>
             </a:r>
           </a:p>
           <a:p xmlns:a="http://schemas.openxmlformats.org/drawingml/2006/main">
@@ -2699,7 +2781,7 @@
                 <a:ea typeface="Yu Gothic"/>
                 <a:cs typeface="Yu Gothic"/>
               </a:rPr>
-              <a:t>1 PLAYER　左=人 / 右=CPU</a:t>
+              <a:t>    old_mode</a:t>
             </a:r>
           </a:p>
           <a:p xmlns:a="http://schemas.openxmlformats.org/drawingml/2006/main">
@@ -2723,7 +2805,7 @@
                 <a:ea typeface="Yu Gothic"/>
                 <a:cs typeface="Yu Gothic"/>
               </a:rPr>
-              <a:t>2 PLAYERS 左右とも人</a:t>
+              <a:t/>
             </a:r>
           </a:p>
           <a:p xmlns:a="http://schemas.openxmlformats.org/drawingml/2006/main">
@@ -2747,7 +2829,7 @@
                 <a:ea typeface="Yu Gothic"/>
                 <a:cs typeface="Yu Gothic"/>
               </a:rPr>
-              <a:t>入力　　　キーボード / 2パッド</a:t>
+              <a:t>  pong : PongGameState</a:t>
             </a:r>
           </a:p>
           <a:p xmlns:a="http://schemas.openxmlformats.org/drawingml/2006/main">
@@ -2771,7 +2853,31 @@
                 <a:ea typeface="Yu Gothic"/>
                 <a:cs typeface="Yu Gothic"/>
               </a:rPr>
-              <a:t>勝利条件　3本先取</a:t>
+              <a:t>    paddles / ball / mode</a:t>
+            </a:r>
+          </a:p>
+          <a:p xmlns:a="http://schemas.openxmlformats.org/drawingml/2006/main">
+            <a:pPr algn="l">
+              <a:buNone/>
+              <a:defRPr sz="1575" b="0">
+                <a:solidFill>
+                  <a:srgbClr val="5D625F"/>
+                </a:solidFill>
+                <a:latin typeface="Yu Gothic"/>
+                <a:ea typeface="Yu Gothic"/>
+                <a:cs typeface="Yu Gothic"/>
+              </a:defRPr>
+            </a:pPr>
+            <a:r>
+              <a:rPr sz="1575" b="0">
+                <a:solidFill>
+                  <a:srgbClr val="5D625F"/>
+                </a:solidFill>
+                <a:latin typeface="Yu Gothic"/>
+                <a:ea typeface="Yu Gothic"/>
+                <a:cs typeface="Yu Gothic"/>
+              </a:rPr>
+              <a:t>    scores / frame</a:t>
             </a:r>
           </a:p>
         </p:txBody>
@@ -4704,7 +4810,7 @@
                 <a:ea typeface="Yu Gothic"/>
                 <a:cs typeface="Yu Gothic"/>
               </a:rPr>
-              <a:t>1P / 2Pを同じ対戦ループで切り替える</a:t>
+              <a:t>GameContextからPONG固有状態だけを渡す</a:t>
             </a:r>
           </a:p>
         </p:txBody>
@@ -4880,7 +4986,7 @@
                 <a:ea typeface="Consolas"/>
                 <a:cs typeface="Consolas"/>
               </a:rPr>
-              <a:t>mode = title_screen();</a:t>
+              <a:t>static void application_loop(</a:t>
             </a:r>
           </a:p>
           <a:p xmlns:a="http://schemas.openxmlformats.org/drawingml/2006/main">
@@ -4904,7 +5010,7 @@
                 <a:ea typeface="Consolas"/>
                 <a:cs typeface="Consolas"/>
               </a:rPr>
-              <a:t/>
+              <a:t>  GameContext *context) {</a:t>
             </a:r>
           </a:p>
           <a:p xmlns:a="http://schemas.openxmlformats.org/drawingml/2006/main">
@@ -4928,7 +5034,7 @@
                 <a:ea typeface="Consolas"/>
                 <a:cs typeface="Consolas"/>
               </a:rPr>
-              <a:t>pong_init(&amp;state, mode);</a:t>
+              <a:t>  int mode;</a:t>
             </a:r>
           </a:p>
           <a:p xmlns:a="http://schemas.openxmlformats.org/drawingml/2006/main">
@@ -4945,7 +5051,7 @@
                   <a:srgbClr val="FFFFFF"/>
                 </a:solidFill>
               </a:rPr>
-              <a:t>winner = pong_match(&amp;state);</a:t>
+              <a:t>  int winner;</a:t>
             </a:r>
           </a:p>
           <a:p xmlns:a="http://schemas.openxmlformats.org/drawingml/2006/main">
@@ -4993,7 +5099,7 @@
                 <a:ea typeface="Consolas"/>
                 <a:cs typeface="Consolas"/>
               </a:rPr>
-              <a:t>if (winner != 0)</a:t>
+              <a:t>  while ((mode = title_screen()) != 0) {</a:t>
             </a:r>
           </a:p>
           <a:p xmlns:a="http://schemas.openxmlformats.org/drawingml/2006/main">
@@ -5010,7 +5116,7 @@
                   <a:srgbClr val="FFFFFF"/>
                 </a:solidFill>
               </a:rPr>
-              <a:t>  winner_screen(mode, winner);</a:t>
+              <a:t>    pong_init(&amp;context-&gt;pong, mode);</a:t>
             </a:r>
           </a:p>
           <a:p xmlns:a="http://schemas.openxmlformats.org/drawingml/2006/main">
@@ -5034,7 +5140,7 @@
                 <a:ea typeface="Consolas"/>
                 <a:cs typeface="Consolas"/>
               </a:rPr>
-              <a:t/>
+              <a:t>    winner = pong_match(&amp;context-&gt;pong);</a:t>
             </a:r>
           </a:p>
           <a:p xmlns:a="http://schemas.openxmlformats.org/drawingml/2006/main">
@@ -5058,7 +5164,24 @@
                 <a:ea typeface="Consolas"/>
                 <a:cs typeface="Consolas"/>
               </a:rPr>
-              <a:t>/* next: title_screen() */</a:t>
+              <a:t>  }</a:t>
+            </a:r>
+          </a:p>
+          <a:p xmlns:a="http://schemas.openxmlformats.org/drawingml/2006/main">
+            <a:pPr>
+              <a:defRPr>
+                <a:solidFill>
+                  <a:srgbClr val="FFFFFF"/>
+                </a:solidFill>
+              </a:defRPr>
+            </a:pPr>
+            <a:r>
+              <a:rPr>
+                <a:solidFill>
+                  <a:srgbClr val="FFFFFF"/>
+                </a:solidFill>
+              </a:rPr>
+              <a:t>}</a:t>
             </a:r>
           </a:p>
         </p:txBody>
@@ -5115,7 +5238,7 @@
                 <a:ea typeface="Yu Gothic"/>
                 <a:cs typeface="Yu Gothic"/>
               </a:rPr>
-              <a:t>モードごとの差分</a:t>
+              <a:t>依存関係の境界</a:t>
             </a:r>
           </a:p>
         </p:txBody>
@@ -5172,7 +5295,7 @@
                 <a:ea typeface="Consolas"/>
                 <a:cs typeface="Consolas"/>
               </a:rPr>
-              <a:t>01  左は常にプレイヤー</a:t>
+              <a:t>01  lifecycleはGameContextを受け取る</a:t>
             </a:r>
           </a:p>
           <a:p xmlns:a="http://schemas.openxmlformats.org/drawingml/2006/main">
@@ -5196,7 +5319,7 @@
                 <a:ea typeface="Consolas"/>
                 <a:cs typeface="Consolas"/>
               </a:rPr>
-              <a:t>02  1Pの右はCPU</a:t>
+              <a:t>02  old_modeはApplicationStateに保持</a:t>
             </a:r>
           </a:p>
           <a:p xmlns:a="http://schemas.openxmlformats.org/drawingml/2006/main">
@@ -5220,7 +5343,7 @@
                 <a:ea typeface="Consolas"/>
                 <a:cs typeface="Consolas"/>
               </a:rPr>
-              <a:t>03  2Pの右はプレイヤー</a:t>
+              <a:t>03  PONG関数はPongGameStateだけを参照</a:t>
             </a:r>
           </a:p>
           <a:p xmlns:a="http://schemas.openxmlformats.org/drawingml/2006/main">
@@ -5244,7 +5367,7 @@
                 <a:ea typeface="Consolas"/>
                 <a:cs typeface="Consolas"/>
               </a:rPr>
-              <a:t>04  3本先取で勝敗決定</a:t>
+              <a:t>04  ゲーム固有状態をapplicationから分離</a:t>
             </a:r>
           </a:p>
           <a:p xmlns:a="http://schemas.openxmlformats.org/drawingml/2006/main">
@@ -5268,7 +5391,7 @@
                 <a:ea typeface="Consolas"/>
                 <a:cs typeface="Consolas"/>
               </a:rPr>
-              <a:t>05  勝者表示後にタイトルへ戻る</a:t>
+              <a:t>05  別ゲームではgame stateだけを交換</a:t>
             </a:r>
           </a:p>
         </p:txBody>
@@ -5325,7 +5448,7 @@
                 <a:ea typeface="Yu Gothic"/>
                 <a:cs typeface="Yu Gothic"/>
               </a:rPr>
-              <a:t>modeと左右スコアで対戦ルールを管理。</a:t>
+              <a:t>共通ライフサイクルとゲーム固有ロジックを型で分離。</a:t>
             </a:r>
           </a:p>
         </p:txBody>

</xml_diff>